<commit_message>
Replace screenshots in Pitch PowerPoint with fully anonymized mock data for privacy compliance
</commit_message>
<xml_diff>
--- a/NSSF_ID_Capture_Tool_Pitch.pptx
+++ b/NSSF_ID_Capture_Tool_Pitch.pptx
@@ -11,10 +11,10 @@
     <p:sldId id="256" r:id="rId3"/>
     <p:sldId id="257" r:id="rId5"/>
     <p:sldId id="258" r:id="rId6"/>
-    <p:sldId id="268" r:id="rId7"/>
-    <p:sldId id="269" r:id="rId8"/>
-    <p:sldId id="270" r:id="rId9"/>
-    <p:sldId id="267" r:id="rId10"/>
+    <p:sldId id="276" r:id="rId7"/>
+    <p:sldId id="277" r:id="rId8"/>
+    <p:sldId id="278" r:id="rId9"/>
+    <p:sldId id="275" r:id="rId10"/>
     <p:sldId id="259" r:id="rId11"/>
     <p:sldId id="260" r:id="rId12"/>
     <p:sldId id="261" r:id="rId13"/>

</xml_diff>

<commit_message>
Update Pitch deck presentation with Samuel Lyomoki Junior developer mock data screenshots
</commit_message>
<xml_diff>
--- a/NSSF_ID_Capture_Tool_Pitch.pptx
+++ b/NSSF_ID_Capture_Tool_Pitch.pptx
@@ -11,10 +11,10 @@
     <p:sldId id="256" r:id="rId3"/>
     <p:sldId id="257" r:id="rId5"/>
     <p:sldId id="258" r:id="rId6"/>
-    <p:sldId id="276" r:id="rId7"/>
-    <p:sldId id="277" r:id="rId8"/>
-    <p:sldId id="278" r:id="rId9"/>
-    <p:sldId id="275" r:id="rId10"/>
+    <p:sldId id="280" r:id="rId7"/>
+    <p:sldId id="281" r:id="rId8"/>
+    <p:sldId id="282" r:id="rId9"/>
+    <p:sldId id="279" r:id="rId10"/>
     <p:sldId id="259" r:id="rId11"/>
     <p:sldId id="260" r:id="rId12"/>
     <p:sldId id="261" r:id="rId13"/>

</xml_diff>